<commit_message>
Replace slide 2 card text with shift schematics and update Fig 3
Co-Authored-By: Claude Opus 5.5 <noreply@anthropic.com>
Claude-Session: https://claude.ai/code/session_018wVMXDRMQETFM428EWoTxC
</commit_message>
<xml_diff>
--- a/EDA/Modeling-Elements/talk-slides/modeling-elements-invited-talk.pptx
+++ b/EDA/Modeling-Elements/talk-slides/modeling-elements-invited-talk.pptx
@@ -4102,149 +4102,30 @@
           </a:p>
         </p:txBody>
       </p:sp>
-      <p:sp>
-        <p:nvSpPr>
-          <p:cNvPr id="9" name="TextBox 8"/>
-          <p:cNvSpPr txBox="1"/>
+      <p:pic>
+        <p:nvPicPr>
+          <p:cNvPr id="9" name="Picture 8" descr="sch-data.png"/>
+          <p:cNvPicPr>
+            <a:picLocks noChangeAspect="1"/>
+          </p:cNvPicPr>
           <p:nvPr/>
-        </p:nvSpPr>
-        <p:spPr>
-          <a:xfrm>
-            <a:off x="457200" y="3200400"/>
-            <a:ext cx="3630168" cy="2377440"/>
+        </p:nvPicPr>
+        <p:blipFill>
+          <a:blip r:embed="rId2"/>
+          <a:stretch>
+            <a:fillRect/>
+          </a:stretch>
+        </p:blipFill>
+        <p:spPr>
+          <a:xfrm>
+            <a:off x="484632" y="3108960"/>
+            <a:ext cx="3566160" cy="2468880"/>
           </a:xfrm>
           <a:prstGeom prst="rect">
             <a:avLst/>
           </a:prstGeom>
-          <a:noFill/>
-        </p:spPr>
-        <p:txBody>
-          <a:bodyPr wrap="square" anchor="t">
-            <a:spAutoFit/>
-          </a:bodyPr>
-          <a:lstStyle/>
-          <a:p>
-            <a:pPr algn="l">
-              <a:spcAft>
-                <a:spcPts val="800"/>
-              </a:spcAft>
-            </a:pPr>
-            <a:r>
-              <a:rPr sz="1500" b="0">
-                <a:solidFill>
-                  <a:srgbClr val="555B66"/>
-                </a:solidFill>
-                <a:latin typeface="Calibri"/>
-              </a:rPr>
-              <a:t>P(X</a:t>
-            </a:r>
-            <a:r>
-              <a:rPr sz="1500" b="0" baseline="-25000">
-                <a:solidFill>
-                  <a:srgbClr val="555B66"/>
-                </a:solidFill>
-                <a:latin typeface="Calibri"/>
-              </a:rPr>
-              <a:t>o</a:t>
-            </a:r>
-            <a:r>
-              <a:rPr sz="1500" b="0">
-                <a:solidFill>
-                  <a:srgbClr val="555B66"/>
-                </a:solidFill>
-                <a:latin typeface="Calibri"/>
-              </a:rPr>
-              <a:t>)</a:t>
-            </a:r>
-            <a:r>
-              <a:rPr sz="1500" b="0" baseline="-25000">
-                <a:solidFill>
-                  <a:srgbClr val="555B66"/>
-                </a:solidFill>
-                <a:latin typeface="Calibri"/>
-              </a:rPr>
-              <a:t>true</a:t>
-            </a:r>
-            <a:r>
-              <a:rPr sz="1500" b="0">
-                <a:solidFill>
-                  <a:srgbClr val="555B66"/>
-                </a:solidFill>
-                <a:latin typeface="Calibri"/>
-              </a:rPr>
-              <a:t> is how inference data is actually distributed.</a:t>
-            </a:r>
-          </a:p>
-          <a:p>
-            <a:pPr algn="l">
-              <a:spcAft>
-                <a:spcPts val="800"/>
-              </a:spcAft>
-            </a:pPr>
-            <a:r>
-              <a:rPr sz="1500" b="0">
-                <a:solidFill>
-                  <a:srgbClr val="555B66"/>
-                </a:solidFill>
-                <a:latin typeface="Calibri"/>
-              </a:rPr>
-              <a:t>P(X</a:t>
-            </a:r>
-            <a:r>
-              <a:rPr sz="1500" b="0" baseline="-25000">
-                <a:solidFill>
-                  <a:srgbClr val="555B66"/>
-                </a:solidFill>
-                <a:latin typeface="Calibri"/>
-              </a:rPr>
-              <a:t>i</a:t>
-            </a:r>
-            <a:r>
-              <a:rPr sz="1500" b="0">
-                <a:solidFill>
-                  <a:srgbClr val="555B66"/>
-                </a:solidFill>
-                <a:latin typeface="Calibri"/>
-              </a:rPr>
-              <a:t>) must cover P(X</a:t>
-            </a:r>
-            <a:r>
-              <a:rPr sz="1500" b="0" baseline="-25000">
-                <a:solidFill>
-                  <a:srgbClr val="555B66"/>
-                </a:solidFill>
-                <a:latin typeface="Calibri"/>
-              </a:rPr>
-              <a:t>o</a:t>
-            </a:r>
-            <a:r>
-              <a:rPr sz="1500" b="0">
-                <a:solidFill>
-                  <a:srgbClr val="555B66"/>
-                </a:solidFill>
-                <a:latin typeface="Calibri"/>
-              </a:rPr>
-              <a:t>).</a:t>
-            </a:r>
-          </a:p>
-          <a:p>
-            <a:pPr algn="l">
-              <a:spcAft>
-                <a:spcPts val="800"/>
-              </a:spcAft>
-            </a:pPr>
-            <a:r>
-              <a:rPr sz="1500" b="1">
-                <a:solidFill>
-                  <a:srgbClr val="2E75B6"/>
-                </a:solidFill>
-                <a:latin typeface="Calibri"/>
-              </a:rPr>
-              <a:t>Departure → covariate shift</a:t>
-            </a:r>
-          </a:p>
-        </p:txBody>
-      </p:sp>
+        </p:spPr>
+      </p:pic>
       <p:sp>
         <p:nvSpPr>
           <p:cNvPr id="10" name="Rectangle 9"/>
@@ -4324,113 +4205,30 @@
           </a:p>
         </p:txBody>
       </p:sp>
-      <p:sp>
-        <p:nvSpPr>
-          <p:cNvPr id="12" name="TextBox 11"/>
-          <p:cNvSpPr txBox="1"/>
+      <p:pic>
+        <p:nvPicPr>
+          <p:cNvPr id="12" name="Picture 11" descr="sch-model.png"/>
+          <p:cNvPicPr>
+            <a:picLocks noChangeAspect="1"/>
+          </p:cNvPicPr>
           <p:nvPr/>
-        </p:nvSpPr>
-        <p:spPr>
-          <a:xfrm>
-            <a:off x="4279392" y="3200400"/>
-            <a:ext cx="3630168" cy="2377440"/>
+        </p:nvPicPr>
+        <p:blipFill>
+          <a:blip r:embed="rId3"/>
+          <a:stretch>
+            <a:fillRect/>
+          </a:stretch>
+        </p:blipFill>
+        <p:spPr>
+          <a:xfrm>
+            <a:off x="4306824" y="3108960"/>
+            <a:ext cx="3566160" cy="2468880"/>
           </a:xfrm>
           <a:prstGeom prst="rect">
             <a:avLst/>
           </a:prstGeom>
-          <a:noFill/>
-        </p:spPr>
-        <p:txBody>
-          <a:bodyPr wrap="square" anchor="t">
-            <a:spAutoFit/>
-          </a:bodyPr>
-          <a:lstStyle/>
-          <a:p>
-            <a:pPr algn="l">
-              <a:spcAft>
-                <a:spcPts val="800"/>
-              </a:spcAft>
-            </a:pPr>
-            <a:r>
-              <a:rPr sz="1500" b="0">
-                <a:solidFill>
-                  <a:srgbClr val="555B66"/>
-                </a:solidFill>
-                <a:latin typeface="Calibri"/>
-              </a:rPr>
-              <a:t>P(Y|X)</a:t>
-            </a:r>
-            <a:r>
-              <a:rPr sz="1500" b="0" baseline="-25000">
-                <a:solidFill>
-                  <a:srgbClr val="555B66"/>
-                </a:solidFill>
-                <a:latin typeface="Calibri"/>
-              </a:rPr>
-              <a:t>model</a:t>
-            </a:r>
-            <a:r>
-              <a:rPr sz="1500" b="0">
-                <a:solidFill>
-                  <a:srgbClr val="555B66"/>
-                </a:solidFill>
-                <a:latin typeface="Calibri"/>
-              </a:rPr>
-              <a:t> is the relation learned from X</a:t>
-            </a:r>
-            <a:r>
-              <a:rPr sz="1500" b="0" baseline="-25000">
-                <a:solidFill>
-                  <a:srgbClr val="555B66"/>
-                </a:solidFill>
-                <a:latin typeface="Calibri"/>
-              </a:rPr>
-              <a:t>i</a:t>
-            </a:r>
-            <a:r>
-              <a:rPr sz="1500" b="0">
-                <a:solidFill>
-                  <a:srgbClr val="555B66"/>
-                </a:solidFill>
-                <a:latin typeface="Calibri"/>
-              </a:rPr>
-              <a:t>.</a:t>
-            </a:r>
-          </a:p>
-          <a:p>
-            <a:pPr algn="l">
-              <a:spcAft>
-                <a:spcPts val="800"/>
-              </a:spcAft>
-            </a:pPr>
-            <a:r>
-              <a:rPr sz="1500" b="0">
-                <a:solidFill>
-                  <a:srgbClr val="555B66"/>
-                </a:solidFill>
-                <a:latin typeface="Calibri"/>
-              </a:rPr>
-              <a:t>It must stay close to the true P(Y|X).</a:t>
-            </a:r>
-          </a:p>
-          <a:p>
-            <a:pPr algn="l">
-              <a:spcAft>
-                <a:spcPts val="800"/>
-              </a:spcAft>
-            </a:pPr>
-            <a:r>
-              <a:rPr sz="1500" b="1">
-                <a:solidFill>
-                  <a:srgbClr val="C55A11"/>
-                </a:solidFill>
-                <a:latin typeface="Calibri"/>
-              </a:rPr>
-              <a:t>Change after training → concept drift</a:t>
-            </a:r>
-          </a:p>
-        </p:txBody>
-      </p:sp>
+        </p:spPr>
+      </p:pic>
       <p:sp>
         <p:nvSpPr>
           <p:cNvPr id="13" name="Rectangle 12"/>
@@ -4510,95 +4308,30 @@
           </a:p>
         </p:txBody>
       </p:sp>
-      <p:sp>
-        <p:nvSpPr>
-          <p:cNvPr id="15" name="TextBox 14"/>
-          <p:cNvSpPr txBox="1"/>
+      <p:pic>
+        <p:nvPicPr>
+          <p:cNvPr id="15" name="Picture 14" descr="sch-prediction.png"/>
+          <p:cNvPicPr>
+            <a:picLocks noChangeAspect="1"/>
+          </p:cNvPicPr>
           <p:nvPr/>
-        </p:nvSpPr>
-        <p:spPr>
-          <a:xfrm>
-            <a:off x="8101583" y="3200400"/>
-            <a:ext cx="3630168" cy="2377440"/>
+        </p:nvPicPr>
+        <p:blipFill>
+          <a:blip r:embed="rId4"/>
+          <a:stretch>
+            <a:fillRect/>
+          </a:stretch>
+        </p:blipFill>
+        <p:spPr>
+          <a:xfrm>
+            <a:off x="8129015" y="3108960"/>
+            <a:ext cx="3566160" cy="2468880"/>
           </a:xfrm>
           <a:prstGeom prst="rect">
             <a:avLst/>
           </a:prstGeom>
-          <a:noFill/>
-        </p:spPr>
-        <p:txBody>
-          <a:bodyPr wrap="square" anchor="t">
-            <a:spAutoFit/>
-          </a:bodyPr>
-          <a:lstStyle/>
-          <a:p>
-            <a:pPr algn="l">
-              <a:spcAft>
-                <a:spcPts val="800"/>
-              </a:spcAft>
-            </a:pPr>
-            <a:r>
-              <a:rPr sz="1500" b="0">
-                <a:solidFill>
-                  <a:srgbClr val="555B66"/>
-                </a:solidFill>
-                <a:latin typeface="Calibri"/>
-              </a:rPr>
-              <a:t>P(Y)</a:t>
-            </a:r>
-            <a:r>
-              <a:rPr sz="1500" b="0" baseline="-25000">
-                <a:solidFill>
-                  <a:srgbClr val="555B66"/>
-                </a:solidFill>
-                <a:latin typeface="Calibri"/>
-              </a:rPr>
-              <a:t>pred</a:t>
-            </a:r>
-            <a:r>
-              <a:rPr sz="1500" b="0">
-                <a:solidFill>
-                  <a:srgbClr val="555B66"/>
-                </a:solidFill>
-                <a:latin typeface="Calibri"/>
-              </a:rPr>
-              <a:t> averages predictions, weighted by how likely each x is at inference.</a:t>
-            </a:r>
-          </a:p>
-          <a:p>
-            <a:pPr algn="l">
-              <a:spcAft>
-                <a:spcPts val="800"/>
-              </a:spcAft>
-            </a:pPr>
-            <a:r>
-              <a:rPr sz="1500" b="0">
-                <a:solidFill>
-                  <a:srgbClr val="555B66"/>
-                </a:solidFill>
-                <a:latin typeface="Calibri"/>
-              </a:rPr>
-              <a:t>If either factor is off, it departs from the true P(Y).</a:t>
-            </a:r>
-          </a:p>
-          <a:p>
-            <a:pPr algn="l">
-              <a:spcAft>
-                <a:spcPts val="800"/>
-              </a:spcAft>
-            </a:pPr>
-            <a:r>
-              <a:rPr sz="1500" b="1">
-                <a:solidFill>
-                  <a:srgbClr val="388E3C"/>
-                </a:solidFill>
-                <a:latin typeface="Calibri"/>
-              </a:rPr>
-              <a:t>Shift in P(Y) → prior shift</a:t>
-            </a:r>
-          </a:p>
-        </p:txBody>
-      </p:sp>
+        </p:spPr>
+      </p:pic>
       <p:sp>
         <p:nvSpPr>
           <p:cNvPr id="16" name="Rectangle 15"/>

</xml_diff>

<commit_message>
Mark training data X_i in eq. (4) as P(Y|X=x; X_i)
Co-Authored-By: Claude Opus 5.5 <noreply@anthropic.com>
Claude-Session: https://claude.ai/code/session_018wVMXDRMQETFM428EWoTxC
</commit_message>
<xml_diff>
--- a/EDA/Modeling-Elements/talk-slides/modeling-elements-invited-talk.pptx
+++ b/EDA/Modeling-Elements/talk-slides/modeling-elements-invited-talk.pptx
@@ -3955,7 +3955,25 @@
                 </a:solidFill>
                 <a:latin typeface="Calibri"/>
               </a:rPr>
-              <a:t>P(Y | X=x)</a:t>
+              <a:t>P(Y | X=x; X</a:t>
+            </a:r>
+            <a:r>
+              <a:rPr sz="2400" b="1" baseline="-25000">
+                <a:solidFill>
+                  <a:srgbClr val="C55A11"/>
+                </a:solidFill>
+                <a:latin typeface="Calibri"/>
+              </a:rPr>
+              <a:t>i</a:t>
+            </a:r>
+            <a:r>
+              <a:rPr sz="2400" b="1">
+                <a:solidFill>
+                  <a:srgbClr val="C55A11"/>
+                </a:solidFill>
+                <a:latin typeface="Calibri"/>
+              </a:rPr>
+              <a:t>)</a:t>
             </a:r>
             <a:r>
               <a:rPr sz="2400" b="1" baseline="-25000">

</xml_diff>

<commit_message>
Restructure around 3x2 shift/drift cells and eq. (5) error split
Each element now has a shift and a drift cell under neutral names, the
prediction error of eq. (4) splits into estimation error and relation
change, and the model estimator axis becomes the estimation error term.
Slides follow the new structure.

Co-Authored-By: Claude Opus 5.5 <noreply@anthropic.com>
Claude-Session: https://claude.ai/code/session_018wVMXDRMQETFM428EWoTxC
</commit_message>
<xml_diff>
--- a/EDA/Modeling-Elements/talk-slides/modeling-elements-invited-talk.pptx
+++ b/EDA/Modeling-Elements/talk-slides/modeling-elements-invited-talk.pptx
@@ -3346,7 +3346,7 @@
                 </a:solidFill>
                 <a:latin typeface="Calibri"/>
               </a:rPr>
-              <a:t>covariate shift</a:t>
+              <a:t>shift · drift</a:t>
             </a:r>
           </a:p>
         </p:txBody>
@@ -3411,7 +3411,7 @@
                 </a:solidFill>
                 <a:latin typeface="Calibri"/>
               </a:rPr>
-              <a:t>conditional relation</a:t>
+              <a:t>relation X → Y</a:t>
             </a:r>
           </a:p>
           <a:p>
@@ -3423,7 +3423,7 @@
                 </a:solidFill>
                 <a:latin typeface="Calibri"/>
               </a:rPr>
-              <a:t>concept drift</a:t>
+              <a:t>shift · drift</a:t>
             </a:r>
           </a:p>
         </p:txBody>
@@ -3500,7 +3500,7 @@
                 </a:solidFill>
                 <a:latin typeface="Calibri"/>
               </a:rPr>
-              <a:t>prior shift</a:t>
+              <a:t>shift · drift</a:t>
             </a:r>
           </a:p>
         </p:txBody>
@@ -3607,7 +3607,25 @@
                 </a:solidFill>
                 <a:latin typeface="Calibri"/>
               </a:rPr>
-              <a:t>Model estimator: orthogonal axis, how P(Y|X) is estimated</a:t>
+              <a:t>Estimation error: P(Y|X)</a:t>
+            </a:r>
+            <a:r>
+              <a:rPr sz="1400" b="0" baseline="-25000">
+                <a:solidFill>
+                  <a:srgbClr val="6A4C93"/>
+                </a:solidFill>
+                <a:latin typeface="Calibri"/>
+              </a:rPr>
+              <a:t>model</a:t>
+            </a:r>
+            <a:r>
+              <a:rPr sz="1400" b="0">
+                <a:solidFill>
+                  <a:srgbClr val="6A4C93"/>
+                </a:solidFill>
+                <a:latin typeface="Calibri"/>
+              </a:rPr>
+              <a:t> departs from the true P(Y|X), set at training</a:t>
             </a:r>
           </a:p>
         </p:txBody>
@@ -3714,7 +3732,7 @@
                 </a:solidFill>
                 <a:latin typeface="Calibri"/>
               </a:rPr>
-              <a:t>Manufacturing is X → Y</a:t>
+              <a:t>Change mode</a:t>
             </a:r>
           </a:p>
           <a:p>
@@ -3722,11 +3740,23 @@
             <a:r>
               <a:rPr sz="1700" b="0">
                 <a:solidFill>
-                  <a:srgbClr val="555B66"/>
-                </a:solidFill>
-                <a:latin typeface="Calibri"/>
-              </a:rPr>
-              <a:t>A shift in P(Y) is mostly the result of a change in P(X) or P(Y|X).</a:t>
+                  <a:srgbClr val="1F2A44"/>
+                </a:solidFill>
+                <a:latin typeface="Calibri"/>
+              </a:rPr>
+              <a:t>Shift: changes at once</a:t>
+            </a:r>
+          </a:p>
+          <a:p>
+            <a:pPr algn="l"/>
+            <a:r>
+              <a:rPr sz="1700" b="0">
+                <a:solidFill>
+                  <a:srgbClr val="1F2A44"/>
+                </a:solidFill>
+                <a:latin typeface="Calibri"/>
+              </a:rPr>
+              <a:t>Drift: changes gradually</a:t>
             </a:r>
           </a:p>
         </p:txBody>
@@ -4418,67 +4448,67 @@
           <a:p>
             <a:pPr algn="ctr"/>
             <a:r>
-              <a:rPr sz="1700" b="0">
+              <a:rPr sz="1600" b="1">
                 <a:solidFill>
                   <a:srgbClr val="1F2A44"/>
                 </a:solidFill>
                 <a:latin typeface="Calibri"/>
               </a:rPr>
-              <a:t>Eq. holds only if </a:t>
-            </a:r>
-            <a:r>
-              <a:rPr sz="1700" b="1">
+              <a:t>Error = </a:t>
+            </a:r>
+            <a:r>
+              <a:rPr sz="1600" b="1">
+                <a:solidFill>
+                  <a:srgbClr val="C55A11"/>
+                </a:solidFill>
+                <a:latin typeface="Calibri"/>
+              </a:rPr>
+              <a:t>estimation error</a:t>
+            </a:r>
+            <a:r>
+              <a:rPr sz="1600" b="0">
                 <a:solidFill>
                   <a:srgbClr val="1F2A44"/>
                 </a:solidFill>
                 <a:latin typeface="Calibri"/>
               </a:rPr>
-              <a:t>X</a:t>
-            </a:r>
-            <a:r>
-              <a:rPr sz="1700" b="1" baseline="-25000">
+              <a:t> (model vs true at training)  +  </a:t>
+            </a:r>
+            <a:r>
+              <a:rPr sz="1600" b="1">
+                <a:solidFill>
+                  <a:srgbClr val="C55A11"/>
+                </a:solidFill>
+                <a:latin typeface="Calibri"/>
+              </a:rPr>
+              <a:t>relation change</a:t>
+            </a:r>
+            <a:r>
+              <a:rPr sz="1600" b="0">
                 <a:solidFill>
                   <a:srgbClr val="1F2A44"/>
                 </a:solidFill>
                 <a:latin typeface="Calibri"/>
               </a:rPr>
+              <a:t> (true at training vs now),  weighted by P(X</a:t>
+            </a:r>
+            <a:r>
+              <a:rPr sz="1600" b="0" baseline="-25000">
+                <a:solidFill>
+                  <a:srgbClr val="1F2A44"/>
+                </a:solidFill>
+                <a:latin typeface="Calibri"/>
+              </a:rPr>
               <a:t>o</a:t>
             </a:r>
             <a:r>
-              <a:rPr sz="1700" b="0">
+              <a:rPr sz="1600" b="0">
                 <a:solidFill>
                   <a:srgbClr val="1F2A44"/>
                 </a:solidFill>
                 <a:latin typeface="Calibri"/>
               </a:rPr>
-              <a:t> stays within the range of </a:t>
-            </a:r>
-            <a:r>
-              <a:rPr sz="1700" b="1">
-                <a:solidFill>
-                  <a:srgbClr val="1F2A44"/>
-                </a:solidFill>
-                <a:latin typeface="Calibri"/>
-              </a:rPr>
-              <a:t>X</a:t>
-            </a:r>
-            <a:r>
-              <a:rPr sz="1700" b="1" baseline="-25000">
-                <a:solidFill>
-                  <a:srgbClr val="1F2A44"/>
-                </a:solidFill>
-                <a:latin typeface="Calibri"/>
-              </a:rPr>
-              <a:t>i</a:t>
-            </a:r>
-            <a:r>
-              <a:rPr sz="1700" b="0">
-                <a:solidFill>
-                  <a:srgbClr val="1F2A44"/>
-                </a:solidFill>
-                <a:latin typeface="Calibri"/>
-              </a:rPr>
-              <a:t> and the true P(Y|X) does not change after training.</a:t>
+              <a:t>)</a:t>
             </a:r>
           </a:p>
         </p:txBody>
@@ -4531,7 +4561,7 @@
                 </a:solidFill>
                 <a:latin typeface="Calibri"/>
               </a:rPr>
-              <a:t>Four Axes: Detect, Respond, Validate</a:t>
+              <a:t>Six Cells and Estimation Error</a:t>
             </a:r>
           </a:p>
         </p:txBody>
@@ -4566,7 +4596,7 @@
                 </a:solidFill>
                 <a:latin typeface="Calibri"/>
               </a:rPr>
-              <a:t>Observation pins down when a change happened; levers fit the model while assuming a change</a:t>
+              <a:t>Shift: compare two sets  ·  Drift: track per time window</a:t>
             </a:r>
           </a:p>
         </p:txBody>
@@ -4728,7 +4758,7 @@
                 </a:solidFill>
                 <a:latin typeface="Calibri"/>
               </a:rPr>
-              <a:t>P(X)  Covariate shift</a:t>
+              <a:t>P(X)  shift · drift</a:t>
             </a:r>
           </a:p>
           <a:p>
@@ -4744,7 +4774,7 @@
                 </a:solidFill>
                 <a:latin typeface="Calibri"/>
               </a:rPr>
-              <a:t>Detect: </a:t>
+              <a:t>Shift: </a:t>
             </a:r>
             <a:r>
               <a:rPr sz="1500" b="0">
@@ -4753,7 +4783,7 @@
                 </a:solidFill>
                 <a:latin typeface="Calibri"/>
               </a:rPr>
-              <a:t>PSI·KS·KL; MMD, domain classifier, Hotelling T²·SPE, autoencoder error</a:t>
+              <a:t>PSI·KS, MMD, domain classifier</a:t>
             </a:r>
           </a:p>
           <a:p>
@@ -4769,7 +4799,7 @@
                 </a:solidFill>
                 <a:latin typeface="Calibri"/>
               </a:rPr>
-              <a:t>Respond: </a:t>
+              <a:t>Drift: </a:t>
             </a:r>
             <a:r>
               <a:rPr sz="1500" b="0">
@@ -4778,7 +4808,7 @@
                 </a:solidFill>
                 <a:latin typeface="Calibri"/>
               </a:rPr>
-              <a:t>Importance weighting, domain adaptation, metrology sampling plan</a:t>
+              <a:t>T²·SPE control chart, windowed PSI</a:t>
             </a:r>
           </a:p>
           <a:p>
@@ -4794,7 +4824,7 @@
                 </a:solidFill>
                 <a:latin typeface="Calibri"/>
               </a:rPr>
-              <a:t>Validate: </a:t>
+              <a:t>Respond: </a:t>
             </a:r>
             <a:r>
               <a:rPr sz="1500" b="0">
@@ -4803,7 +4833,7 @@
                 </a:solidFill>
                 <a:latin typeface="Calibri"/>
               </a:rPr>
-              <a:t>Adversarial validation</a:t>
+              <a:t>importance weighting, domain adaptation; recent-window retraining</a:t>
             </a:r>
           </a:p>
         </p:txBody>
@@ -4930,7 +4960,7 @@
                 </a:solidFill>
                 <a:latin typeface="Calibri"/>
               </a:rPr>
-              <a:t>P(Y)  Prior shift</a:t>
+              <a:t>P(Y)  shift · drift</a:t>
             </a:r>
           </a:p>
           <a:p>
@@ -4946,7 +4976,7 @@
                 </a:solidFill>
                 <a:latin typeface="Calibri"/>
               </a:rPr>
-              <a:t>Detect: </a:t>
+              <a:t>Shift: </a:t>
             </a:r>
             <a:r>
               <a:rPr sz="1500" b="0">
@@ -4955,7 +4985,7 @@
                 </a:solidFill>
                 <a:latin typeface="Calibri"/>
               </a:rPr>
-              <a:t>Metrology distribution (KS·PSI), SPC (Shewhart·EWMA), P(Y)pred monitoring</a:t>
+              <a:t>KS·PSI on metrology values, Shewhart chart</a:t>
             </a:r>
           </a:p>
           <a:p>
@@ -4971,7 +5001,7 @@
                 </a:solidFill>
                 <a:latin typeface="Calibri"/>
               </a:rPr>
-              <a:t>Respond: </a:t>
+              <a:t>Drift: </a:t>
             </a:r>
             <a:r>
               <a:rPr sz="1500" b="0">
@@ -4980,7 +5010,7 @@
                 </a:solidFill>
                 <a:latin typeface="Calibri"/>
               </a:rPr>
-              <a:t>Target engineering (log, Box-Cox, spatial decomposition), per-group scaling</a:t>
+              <a:t>EWMA chart, P(Y)pred monitoring</a:t>
             </a:r>
           </a:p>
           <a:p>
@@ -4996,7 +5026,7 @@
                 </a:solidFill>
                 <a:latin typeface="Calibri"/>
               </a:rPr>
-              <a:t>Validate: </a:t>
+              <a:t>Respond: </a:t>
             </a:r>
             <a:r>
               <a:rPr sz="1500" b="0">
@@ -5005,7 +5035,7 @@
                 </a:solidFill>
                 <a:latin typeface="Calibri"/>
               </a:rPr>
-              <a:t>Error per spec and per group</a:t>
+              <a:t>target redefinition; per-group scaling, target engineering</a:t>
             </a:r>
           </a:p>
         </p:txBody>
@@ -5132,7 +5162,7 @@
                 </a:solidFill>
                 <a:latin typeface="Calibri"/>
               </a:rPr>
-              <a:t>P(Y|X)  Concept drift</a:t>
+              <a:t>P(Y|X)  shift · drift</a:t>
             </a:r>
           </a:p>
           <a:p>
@@ -5148,7 +5178,7 @@
                 </a:solidFill>
                 <a:latin typeface="Calibri"/>
               </a:rPr>
-              <a:t>Detect: </a:t>
+              <a:t>Shift: </a:t>
             </a:r>
             <a:r>
               <a:rPr sz="1500" b="0">
@@ -5157,7 +5187,7 @@
                 </a:solidFill>
                 <a:latin typeface="Calibri"/>
               </a:rPr>
-              <a:t>Binning CDT, residual CUSUM, Page-Hinkley, ADWIN, windowed I(Xk;Y)</a:t>
+              <a:t>Binning CDT, event-split comparison</a:t>
             </a:r>
           </a:p>
           <a:p>
@@ -5173,7 +5203,7 @@
                 </a:solidFill>
                 <a:latin typeface="Calibri"/>
               </a:rPr>
-              <a:t>Respond: </a:t>
+              <a:t>Drift: </a:t>
             </a:r>
             <a:r>
               <a:rPr sz="1500" b="0">
@@ -5182,7 +5212,7 @@
                 </a:solidFill>
                 <a:latin typeface="Calibri"/>
               </a:rPr>
-              <a:t>Recent-window retraining, recency weighting, adaptive VM update, Z(t) proxies</a:t>
+              <a:t>residual CUSUM, Page-Hinkley, ADWIN</a:t>
             </a:r>
           </a:p>
           <a:p>
@@ -5198,7 +5228,7 @@
                 </a:solidFill>
                 <a:latin typeface="Calibri"/>
               </a:rPr>
-              <a:t>Validate: </a:t>
+              <a:t>Respond: </a:t>
             </a:r>
             <a:r>
               <a:rPr sz="1500" b="0">
@@ -5207,7 +5237,7 @@
                 </a:solidFill>
                 <a:latin typeface="Calibri"/>
               </a:rPr>
-              <a:t>Temporal CV, lot group split</a:t>
+              <a:t>retrain after event; recency weighting, adaptive VM update</a:t>
             </a:r>
           </a:p>
         </p:txBody>
@@ -5334,7 +5364,7 @@
                 </a:solidFill>
                 <a:latin typeface="Calibri"/>
               </a:rPr>
-              <a:t>Model estimator  (orthogonal)</a:t>
+              <a:t>Estimation error</a:t>
             </a:r>
           </a:p>
           <a:p>
@@ -5359,7 +5389,7 @@
                 </a:solidFill>
                 <a:latin typeface="Calibri"/>
               </a:rPr>
-              <a:t>Train–validation gap; windowed R²·RMSE</a:t>
+              <a:t>train–validation gap, out-of-range check</a:t>
             </a:r>
           </a:p>
           <a:p>
@@ -5384,7 +5414,7 @@
                 </a:solidFill>
                 <a:latin typeface="Calibri"/>
               </a:rPr>
-              <a:t>PLS·ridge·lasso, tree ensembles, GP·conformal, physics hybrid, Optuna</a:t>
+              <a:t>PLS·ridge·lasso, tree ensembles, GP·conformal</a:t>
             </a:r>
           </a:p>
           <a:p>
@@ -5409,7 +5439,7 @@
                 </a:solidFill>
                 <a:latin typeface="Calibri"/>
               </a:rPr>
-              <a:t>Lot group split + temporal CV; R², RMSE, interval coverage</a:t>
+              <a:t>lot group split + temporal CV</a:t>
             </a:r>
           </a:p>
         </p:txBody>

</xml_diff>